<commit_message>
fix: corrige PPTX gerado com slides em branco
Bug: parser usava el.w/el.h mas build_pptx.js espera el.width/el.height.
Com undefined, pxToInches retornava NaN e os elementos não eram renderizados.
Também corrigido: cores dos itens de lista em slides escuros (invert/section).

Co-Authored-By: Claude Sonnet 4.6 <noreply@anthropic.com>
</commit_message>
<xml_diff>
--- a/hubspoke-apresentacao.pptx
+++ b/hubspoke-apresentacao.pptx
@@ -2414,7 +2414,7 @@
         <p:spPr>
           <a:xfrm>
             <a:off x="571500" y="1107281"/>
-            <a:ext cx="0" cy="0"/>
+            <a:ext cx="5943600" cy="1357313"/>
           </a:xfrm>
           <a:prstGeom prst="rect">
             <a:avLst/>
@@ -2455,7 +2455,7 @@
         <p:spPr>
           <a:xfrm>
             <a:off x="571500" y="3250406"/>
-            <a:ext cx="0" cy="0"/>
+            <a:ext cx="8001000" cy="392906"/>
           </a:xfrm>
           <a:prstGeom prst="rect">
             <a:avLst/>
@@ -2496,7 +2496,7 @@
         <p:spPr>
           <a:xfrm>
             <a:off x="571500" y="3757613"/>
-            <a:ext cx="0" cy="0"/>
+            <a:ext cx="8001000" cy="285750"/>
           </a:xfrm>
           <a:prstGeom prst="rect">
             <a:avLst/>
@@ -2569,7 +2569,7 @@
         <p:spPr>
           <a:xfrm>
             <a:off x="457200" y="428625"/>
-            <a:ext cx="0" cy="0"/>
+            <a:ext cx="8229600" cy="928688"/>
           </a:xfrm>
           <a:prstGeom prst="rect">
             <a:avLst/>
@@ -2610,7 +2610,7 @@
         <p:spPr>
           <a:xfrm>
             <a:off x="457200" y="1471613"/>
-            <a:ext cx="0" cy="0"/>
+            <a:ext cx="8229600" cy="1171575"/>
           </a:xfrm>
           <a:prstGeom prst="rect">
             <a:avLst/>
@@ -2627,7 +2627,7 @@
             <a:r>
               <a:rPr lang="en-US" sz="1400" b="1" dirty="0">
                 <a:solidFill>
-                  <a:srgbClr val="202124"/>
+                  <a:srgbClr val="FFFFFF"/>
                 </a:solidFill>
                 <a:latin typeface="Arial" pitchFamily="34" charset="0"/>
                 <a:ea typeface="Arial" pitchFamily="34" charset="-122"/>
@@ -2641,7 +2641,7 @@
             <a:r>
               <a:rPr lang="en-US" sz="1400" dirty="0">
                 <a:solidFill>
-                  <a:srgbClr val="202124"/>
+                  <a:srgbClr val="FFFFFF"/>
                 </a:solidFill>
                 <a:latin typeface="Arial" pitchFamily="34" charset="0"/>
                 <a:ea typeface="Arial" pitchFamily="34" charset="-122"/>
@@ -2655,7 +2655,7 @@
             <a:r>
               <a:rPr lang="en-US" sz="1400" dirty="0">
                 <a:solidFill>
-                  <a:srgbClr val="202124"/>
+                  <a:srgbClr val="FFFFFF"/>
                 </a:solidFill>
                 <a:latin typeface="Arial" pitchFamily="34" charset="0"/>
                 <a:ea typeface="Arial" pitchFamily="34" charset="-122"/>
@@ -2701,7 +2701,7 @@
         <p:spPr>
           <a:xfrm>
             <a:off x="457200" y="428625"/>
-            <a:ext cx="0" cy="0"/>
+            <a:ext cx="8229600" cy="928688"/>
           </a:xfrm>
           <a:prstGeom prst="rect">
             <a:avLst/>
@@ -2742,7 +2742,7 @@
         <p:spPr>
           <a:xfrm>
             <a:off x="457200" y="1471613"/>
-            <a:ext cx="0" cy="0"/>
+            <a:ext cx="8229600" cy="285750"/>
           </a:xfrm>
           <a:prstGeom prst="rect">
             <a:avLst/>
@@ -2783,7 +2783,7 @@
         <p:spPr>
           <a:xfrm>
             <a:off x="457200" y="1871663"/>
-            <a:ext cx="0" cy="0"/>
+            <a:ext cx="8229600" cy="1171575"/>
           </a:xfrm>
           <a:prstGeom prst="rect">
             <a:avLst/>
@@ -2881,7 +2881,7 @@
         <p:spPr>
           <a:xfrm>
             <a:off x="457200" y="428625"/>
-            <a:ext cx="0" cy="0"/>
+            <a:ext cx="8229600" cy="928688"/>
           </a:xfrm>
           <a:prstGeom prst="rect">
             <a:avLst/>
@@ -2922,7 +2922,7 @@
         <p:spPr>
           <a:xfrm>
             <a:off x="457200" y="1471613"/>
-            <a:ext cx="0" cy="0"/>
+            <a:ext cx="8229600" cy="1171575"/>
           </a:xfrm>
           <a:prstGeom prst="rect">
             <a:avLst/>
@@ -2939,7 +2939,7 @@
             <a:r>
               <a:rPr lang="en-US" sz="1400" dirty="0">
                 <a:solidFill>
-                  <a:srgbClr val="202124"/>
+                  <a:srgbClr val="FFFFFF"/>
                 </a:solidFill>
                 <a:latin typeface="Arial" pitchFamily="34" charset="0"/>
                 <a:ea typeface="Arial" pitchFamily="34" charset="-122"/>
@@ -2953,7 +2953,7 @@
             <a:r>
               <a:rPr lang="en-US" sz="1400" b="1" dirty="0">
                 <a:solidFill>
-                  <a:srgbClr val="202124"/>
+                  <a:srgbClr val="FFFFFF"/>
                 </a:solidFill>
                 <a:latin typeface="Arial" pitchFamily="34" charset="0"/>
                 <a:ea typeface="Arial" pitchFamily="34" charset="-122"/>
@@ -2967,7 +2967,7 @@
             <a:r>
               <a:rPr lang="en-US" sz="1400" dirty="0">
                 <a:solidFill>
-                  <a:srgbClr val="202124"/>
+                  <a:srgbClr val="FFFFFF"/>
                 </a:solidFill>
                 <a:latin typeface="Arial" pitchFamily="34" charset="0"/>
                 <a:ea typeface="Arial" pitchFamily="34" charset="-122"/>
@@ -3013,7 +3013,7 @@
         <p:spPr>
           <a:xfrm>
             <a:off x="457200" y="428625"/>
-            <a:ext cx="0" cy="0"/>
+            <a:ext cx="8229600" cy="928688"/>
           </a:xfrm>
           <a:prstGeom prst="rect">
             <a:avLst/>
@@ -3054,7 +3054,7 @@
         <p:spPr>
           <a:xfrm>
             <a:off x="457200" y="1471613"/>
-            <a:ext cx="0" cy="0"/>
+            <a:ext cx="8229600" cy="285750"/>
           </a:xfrm>
           <a:prstGeom prst="rect">
             <a:avLst/>
@@ -3095,7 +3095,7 @@
         <p:spPr>
           <a:xfrm>
             <a:off x="457200" y="1871663"/>
-            <a:ext cx="0" cy="0"/>
+            <a:ext cx="8229600" cy="1171575"/>
           </a:xfrm>
           <a:prstGeom prst="rect">
             <a:avLst/>
@@ -3193,7 +3193,7 @@
         <p:spPr>
           <a:xfrm>
             <a:off x="457200" y="428625"/>
-            <a:ext cx="0" cy="0"/>
+            <a:ext cx="8229600" cy="928688"/>
           </a:xfrm>
           <a:prstGeom prst="rect">
             <a:avLst/>
@@ -3234,7 +3234,7 @@
         <p:spPr>
           <a:xfrm>
             <a:off x="457200" y="1471613"/>
-            <a:ext cx="0" cy="0"/>
+            <a:ext cx="8229600" cy="1171575"/>
           </a:xfrm>
           <a:prstGeom prst="rect">
             <a:avLst/>
@@ -3251,7 +3251,7 @@
             <a:r>
               <a:rPr lang="en-US" sz="1400" b="1" dirty="0">
                 <a:solidFill>
-                  <a:srgbClr val="202124"/>
+                  <a:srgbClr val="FFFFFF"/>
                 </a:solidFill>
                 <a:latin typeface="Arial" pitchFamily="34" charset="0"/>
                 <a:ea typeface="Arial" pitchFamily="34" charset="-122"/>
@@ -3265,7 +3265,7 @@
             <a:r>
               <a:rPr lang="en-US" sz="1400" dirty="0">
                 <a:solidFill>
-                  <a:srgbClr val="202124"/>
+                  <a:srgbClr val="FFFFFF"/>
                 </a:solidFill>
                 <a:latin typeface="Arial" pitchFamily="34" charset="0"/>
                 <a:ea typeface="Arial" pitchFamily="34" charset="-122"/>
@@ -3279,7 +3279,7 @@
             <a:r>
               <a:rPr lang="en-US" sz="1400" dirty="0">
                 <a:solidFill>
-                  <a:srgbClr val="202124"/>
+                  <a:srgbClr val="FFFFFF"/>
                 </a:solidFill>
                 <a:latin typeface="Arial" pitchFamily="34" charset="0"/>
                 <a:ea typeface="Arial" pitchFamily="34" charset="-122"/>
@@ -3325,7 +3325,7 @@
         <p:spPr>
           <a:xfrm>
             <a:off x="457200" y="428625"/>
-            <a:ext cx="0" cy="0"/>
+            <a:ext cx="8229600" cy="928688"/>
           </a:xfrm>
           <a:prstGeom prst="rect">
             <a:avLst/>
@@ -3366,7 +3366,7 @@
         <p:spPr>
           <a:xfrm>
             <a:off x="457200" y="1471613"/>
-            <a:ext cx="0" cy="0"/>
+            <a:ext cx="8229600" cy="285750"/>
           </a:xfrm>
           <a:prstGeom prst="rect">
             <a:avLst/>
@@ -3407,7 +3407,7 @@
         <p:spPr>
           <a:xfrm>
             <a:off x="457200" y="1871663"/>
-            <a:ext cx="0" cy="0"/>
+            <a:ext cx="8229600" cy="1171575"/>
           </a:xfrm>
           <a:prstGeom prst="rect">
             <a:avLst/>
@@ -3505,7 +3505,7 @@
         <p:spPr>
           <a:xfrm>
             <a:off x="457200" y="428625"/>
-            <a:ext cx="0" cy="0"/>
+            <a:ext cx="8229600" cy="928688"/>
           </a:xfrm>
           <a:prstGeom prst="rect">
             <a:avLst/>
@@ -3546,7 +3546,7 @@
         <p:spPr>
           <a:xfrm>
             <a:off x="457200" y="1471613"/>
-            <a:ext cx="0" cy="0"/>
+            <a:ext cx="8229600" cy="1171575"/>
           </a:xfrm>
           <a:prstGeom prst="rect">
             <a:avLst/>
@@ -3563,7 +3563,7 @@
             <a:r>
               <a:rPr lang="en-US" sz="1400" dirty="0">
                 <a:solidFill>
-                  <a:srgbClr val="202124"/>
+                  <a:srgbClr val="FFFFFF"/>
                 </a:solidFill>
                 <a:latin typeface="Arial" pitchFamily="34" charset="0"/>
                 <a:ea typeface="Arial" pitchFamily="34" charset="-122"/>
@@ -3577,7 +3577,7 @@
             <a:r>
               <a:rPr lang="en-US" sz="1400" b="1" dirty="0">
                 <a:solidFill>
-                  <a:srgbClr val="202124"/>
+                  <a:srgbClr val="FFFFFF"/>
                 </a:solidFill>
                 <a:latin typeface="Arial" pitchFamily="34" charset="0"/>
                 <a:ea typeface="Arial" pitchFamily="34" charset="-122"/>
@@ -3591,7 +3591,7 @@
             <a:r>
               <a:rPr lang="en-US" sz="1400" dirty="0">
                 <a:solidFill>
-                  <a:srgbClr val="202124"/>
+                  <a:srgbClr val="FFFFFF"/>
                 </a:solidFill>
                 <a:latin typeface="Arial" pitchFamily="34" charset="0"/>
                 <a:ea typeface="Arial" pitchFamily="34" charset="-122"/>
@@ -3717,7 +3717,7 @@
         <p:spPr>
           <a:xfrm>
             <a:off x="457200" y="1821656"/>
-            <a:ext cx="0" cy="0"/>
+            <a:ext cx="8229600" cy="1071563"/>
           </a:xfrm>
           <a:prstGeom prst="rect">
             <a:avLst/>
@@ -3758,7 +3758,7 @@
         <p:spPr>
           <a:xfrm>
             <a:off x="457200" y="428625"/>
-            <a:ext cx="0" cy="0"/>
+            <a:ext cx="8229600" cy="392906"/>
           </a:xfrm>
           <a:prstGeom prst="rect">
             <a:avLst/>
@@ -3831,7 +3831,7 @@
         <p:spPr>
           <a:xfrm>
             <a:off x="457200" y="1821656"/>
-            <a:ext cx="0" cy="0"/>
+            <a:ext cx="8229600" cy="785813"/>
           </a:xfrm>
           <a:prstGeom prst="rect">
             <a:avLst/>
@@ -3897,7 +3897,7 @@
         <p:spPr>
           <a:xfrm>
             <a:off x="457200" y="428625"/>
-            <a:ext cx="0" cy="0"/>
+            <a:ext cx="8229600" cy="928688"/>
           </a:xfrm>
           <a:prstGeom prst="rect">
             <a:avLst/>
@@ -3938,7 +3938,7 @@
         <p:spPr>
           <a:xfrm>
             <a:off x="457200" y="1471613"/>
-            <a:ext cx="0" cy="0"/>
+            <a:ext cx="8229600" cy="1171575"/>
           </a:xfrm>
           <a:prstGeom prst="rect">
             <a:avLst/>
@@ -4036,7 +4036,7 @@
         <p:spPr>
           <a:xfrm>
             <a:off x="457200" y="1821656"/>
-            <a:ext cx="0" cy="0"/>
+            <a:ext cx="8229600" cy="785813"/>
           </a:xfrm>
           <a:prstGeom prst="rect">
             <a:avLst/>
@@ -4102,7 +4102,7 @@
         <p:spPr>
           <a:xfrm>
             <a:off x="457200" y="428625"/>
-            <a:ext cx="0" cy="0"/>
+            <a:ext cx="8229600" cy="928688"/>
           </a:xfrm>
           <a:prstGeom prst="rect">
             <a:avLst/>
@@ -4143,7 +4143,7 @@
         <p:spPr>
           <a:xfrm>
             <a:off x="457200" y="1471613"/>
-            <a:ext cx="0" cy="0"/>
+            <a:ext cx="8229600" cy="285750"/>
           </a:xfrm>
           <a:prstGeom prst="rect">
             <a:avLst/>
@@ -4184,7 +4184,7 @@
         <p:spPr>
           <a:xfrm>
             <a:off x="457200" y="1871663"/>
-            <a:ext cx="0" cy="0"/>
+            <a:ext cx="8229600" cy="1171575"/>
           </a:xfrm>
           <a:prstGeom prst="rect">
             <a:avLst/>
@@ -4282,7 +4282,7 @@
         <p:spPr>
           <a:xfrm>
             <a:off x="457200" y="428625"/>
-            <a:ext cx="0" cy="0"/>
+            <a:ext cx="8229600" cy="928688"/>
           </a:xfrm>
           <a:prstGeom prst="rect">
             <a:avLst/>
@@ -4323,7 +4323,7 @@
         <p:spPr>
           <a:xfrm>
             <a:off x="457200" y="1471613"/>
-            <a:ext cx="0" cy="0"/>
+            <a:ext cx="8229600" cy="1171575"/>
           </a:xfrm>
           <a:prstGeom prst="rect">
             <a:avLst/>
@@ -4340,7 +4340,7 @@
             <a:r>
               <a:rPr lang="en-US" sz="1400" dirty="0">
                 <a:solidFill>
-                  <a:srgbClr val="202124"/>
+                  <a:srgbClr val="FFFFFF"/>
                 </a:solidFill>
                 <a:latin typeface="Arial" pitchFamily="34" charset="0"/>
                 <a:ea typeface="Arial" pitchFamily="34" charset="-122"/>
@@ -4354,7 +4354,7 @@
             <a:r>
               <a:rPr lang="en-US" sz="1400" b="1" dirty="0">
                 <a:solidFill>
-                  <a:srgbClr val="202124"/>
+                  <a:srgbClr val="FFFFFF"/>
                 </a:solidFill>
                 <a:latin typeface="Arial" pitchFamily="34" charset="0"/>
                 <a:ea typeface="Arial" pitchFamily="34" charset="-122"/>
@@ -4368,7 +4368,7 @@
             <a:r>
               <a:rPr lang="en-US" sz="1400" dirty="0">
                 <a:solidFill>
-                  <a:srgbClr val="202124"/>
+                  <a:srgbClr val="FFFFFF"/>
                 </a:solidFill>
                 <a:latin typeface="Arial" pitchFamily="34" charset="0"/>
                 <a:ea typeface="Arial" pitchFamily="34" charset="-122"/>
@@ -4414,7 +4414,7 @@
         <p:spPr>
           <a:xfrm>
             <a:off x="457200" y="1785938"/>
-            <a:ext cx="0" cy="0"/>
+            <a:ext cx="8229600" cy="1071563"/>
           </a:xfrm>
           <a:prstGeom prst="rect">
             <a:avLst/>
@@ -4487,7 +4487,7 @@
         <p:spPr>
           <a:xfrm>
             <a:off x="457200" y="1821656"/>
-            <a:ext cx="0" cy="0"/>
+            <a:ext cx="8229600" cy="785813"/>
           </a:xfrm>
           <a:prstGeom prst="rect">
             <a:avLst/>
@@ -4527,8 +4527,8 @@
         </p:nvSpPr>
         <p:spPr>
           <a:xfrm>
-            <a:off x="457200" y="2714625"/>
-            <a:ext cx="0" cy="0"/>
+            <a:off x="457200" y="2750344"/>
+            <a:ext cx="8229600" cy="571500"/>
           </a:xfrm>
           <a:prstGeom prst="rect">
             <a:avLst/>
@@ -4594,7 +4594,7 @@
         <p:spPr>
           <a:xfrm>
             <a:off x="457200" y="428625"/>
-            <a:ext cx="0" cy="0"/>
+            <a:ext cx="8229600" cy="928688"/>
           </a:xfrm>
           <a:prstGeom prst="rect">
             <a:avLst/>
@@ -4635,7 +4635,7 @@
         <p:spPr>
           <a:xfrm>
             <a:off x="457200" y="1471613"/>
-            <a:ext cx="0" cy="0"/>
+            <a:ext cx="8229600" cy="285750"/>
           </a:xfrm>
           <a:prstGeom prst="rect">
             <a:avLst/>
@@ -4676,7 +4676,7 @@
         <p:spPr>
           <a:xfrm>
             <a:off x="457200" y="1871663"/>
-            <a:ext cx="0" cy="0"/>
+            <a:ext cx="8229600" cy="1171575"/>
           </a:xfrm>
           <a:prstGeom prst="rect">
             <a:avLst/>

</xml_diff>